<commit_message>
fix(datacomp-lm): invert bar chart category order so top filter appears first
</commit_message>
<xml_diff>
--- a/papers/datacomp-lm/deck.pptx
+++ b/papers/datacomp-lm/deck.pptx
@@ -148,7 +148,7 @@
           </c:tx>
           <c:spPr>
             <a:solidFill>
-              <a:srgbClr val="6B5BD6">
+              <a:srgbClr val="D8A0A0">
                 <a:alpha val="90000"/>
               </a:srgbClr>
             </a:solidFill>
@@ -185,7 +185,7 @@
             <c:bubble3D val="0"/>
             <c:spPr>
               <a:solidFill>
-                <a:srgbClr val="6B5BD6"/>
+                <a:srgbClr val="D8A0A0"/>
               </a:solidFill>
               <a:effectLst/>
             </c:spPr>
@@ -196,7 +196,7 @@
             <c:bubble3D val="0"/>
             <c:spPr>
               <a:solidFill>
-                <a:srgbClr val="8B7DD8"/>
+                <a:srgbClr val="DDE5F0"/>
               </a:solidFill>
               <a:effectLst/>
             </c:spPr>
@@ -207,7 +207,7 @@
             <c:bubble3D val="0"/>
             <c:spPr>
               <a:solidFill>
-                <a:srgbClr val="A79DE3"/>
+                <a:srgbClr val="DDE5F0"/>
               </a:solidFill>
               <a:effectLst/>
             </c:spPr>
@@ -218,7 +218,7 @@
             <c:bubble3D val="0"/>
             <c:spPr>
               <a:solidFill>
-                <a:srgbClr val="C3BCEE"/>
+                <a:srgbClr val="DDE5F0"/>
               </a:solidFill>
               <a:effectLst/>
             </c:spPr>
@@ -229,7 +229,7 @@
             <c:bubble3D val="0"/>
             <c:spPr>
               <a:solidFill>
-                <a:srgbClr val="DDE5F0"/>
+                <a:srgbClr val="C3BCEE"/>
               </a:solidFill>
               <a:effectLst/>
             </c:spPr>
@@ -240,7 +240,7 @@
             <c:bubble3D val="0"/>
             <c:spPr>
               <a:solidFill>
-                <a:srgbClr val="DDE5F0"/>
+                <a:srgbClr val="A79DE3"/>
               </a:solidFill>
               <a:effectLst/>
             </c:spPr>
@@ -251,7 +251,7 @@
             <c:bubble3D val="0"/>
             <c:spPr>
               <a:solidFill>
-                <a:srgbClr val="DDE5F0"/>
+                <a:srgbClr val="8B7DD8"/>
               </a:solidFill>
               <a:effectLst/>
             </c:spPr>
@@ -262,7 +262,7 @@
             <c:bubble3D val="0"/>
             <c:spPr>
               <a:solidFill>
-                <a:srgbClr val="D8A0A0"/>
+                <a:srgbClr val="6B5BD6"/>
               </a:solidFill>
               <a:effectLst/>
             </c:spPr>
@@ -274,31 +274,31 @@
                 <c:ptCount val="8"/>
                 <c:lvl>
                   <c:pt idx="0">
-                    <c:v>fastText
-OH-2.5+ELI5</c:v>
+                    <c:v>PageRank</c:v>
                   </c:pt>
                   <c:pt idx="1">
+                    <c:v>BGE</c:v>
+                  </c:pt>
+                  <c:pt idx="2">
+                    <c:v>SemDedup</c:v>
+                  </c:pt>
+                  <c:pt idx="3">
+                    <c:v>RefinedWeb
+repro</c:v>
+                  </c:pt>
+                  <c:pt idx="4">
+                    <c:v>AskLLM</c:v>
+                  </c:pt>
+                  <c:pt idx="5">
+                    <c:v>perplexity</c:v>
+                  </c:pt>
+                  <c:pt idx="6">
                     <c:v>top-k
 logits</c:v>
                   </c:pt>
-                  <c:pt idx="2">
-                    <c:v>perplexity</c:v>
-                  </c:pt>
-                  <c:pt idx="3">
-                    <c:v>AskLLM</c:v>
-                  </c:pt>
-                  <c:pt idx="4">
-                    <c:v>RefinedWeb
-repro</c:v>
-                  </c:pt>
-                  <c:pt idx="5">
-                    <c:v>SemDedup</c:v>
-                  </c:pt>
-                  <c:pt idx="6">
-                    <c:v>BGE</c:v>
-                  </c:pt>
                   <c:pt idx="7">
-                    <c:v>PageRank</c:v>
+                    <c:v>fastText
+OH-2.5+ELI5</c:v>
                   </c:pt>
                 </c:lvl>
               </c:multiLvlStrCache>
@@ -311,28 +311,28 @@
                 <c:formatCode>General</c:formatCode>
                 <c:ptCount val="8"/>
                 <c:pt idx="0">
-                  <c:v>30.2</c:v>
+                  <c:v>26.1</c:v>
                 </c:pt>
                 <c:pt idx="1">
+                  <c:v>27.2</c:v>
+                </c:pt>
+                <c:pt idx="2">
+                  <c:v>27.1</c:v>
+                </c:pt>
+                <c:pt idx="3">
+                  <c:v>27.5</c:v>
+                </c:pt>
+                <c:pt idx="4">
+                  <c:v>28.6</c:v>
+                </c:pt>
+                <c:pt idx="5">
+                  <c:v>29</c:v>
+                </c:pt>
+                <c:pt idx="6">
                   <c:v>29.2</c:v>
                 </c:pt>
-                <c:pt idx="2">
-                  <c:v>29</c:v>
-                </c:pt>
-                <c:pt idx="3">
-                  <c:v>28.6</c:v>
-                </c:pt>
-                <c:pt idx="4">
-                  <c:v>27.5</c:v>
-                </c:pt>
-                <c:pt idx="5">
-                  <c:v>27.1</c:v>
-                </c:pt>
-                <c:pt idx="6">
-                  <c:v>27.2</c:v>
-                </c:pt>
                 <c:pt idx="7">
-                  <c:v>26.1</c:v>
+                  <c:v>30.2</c:v>
                 </c:pt>
               </c:numCache>
             </c:numRef>

</xml_diff>